<commit_message>
Cutover decks: rc9 in production (29 Sept)
rc9, the Next.js 15.5 / React 19 upgrade, merged 29 Sept 09:07 and tagged
at 9dab9a2 (132/132 on staging). The freeze ruleset was lifted for the
merge and restored at 09:08. The decks now show rc9 as the live release,
add 29 Sept to the timeline and the chart, and replace the rc9-window
decision with an owner and date for the first real payment.

Co-Authored-By: Claude Opus 5.5 <noreply@anthropic.com>
</commit_message>
<xml_diff>
--- a/docs/OE_Group_Phase1_Progress.UPDATED.v4.pptx
+++ b/docs/OE_Group_Phase1_Progress.UPDATED.v4.pptx
@@ -211,15 +211,23 @@
             <c:idx val="4"/>
             <c:spPr>
               <a:solidFill>
+                <a:srgbClr val="003366"/>
+              </a:solidFill>
+            </c:spPr>
+          </c:dPt>
+          <c:dPt>
+            <c:idx val="5"/>
+            <c:spPr>
+              <a:solidFill>
                 <a:srgbClr val="1F7A4D"/>
               </a:solidFill>
             </c:spPr>
           </c:dPt>
           <c:cat>
             <c:strRef>
-              <c:f>Sheet1!$A$2:$A$6</c:f>
+              <c:f>Sheet1!$A$2:$A$7</c:f>
               <c:strCache>
-                <c:ptCount val="5"/>
+                <c:ptCount val="6"/>
                 <c:pt idx="0">
                   <c:v>rc4
 23 Sep</c:v>
@@ -240,15 +248,19 @@
                   <c:v>rc8
 28 Sep</c:v>
                 </c:pt>
+                <c:pt idx="5">
+                  <c:v>rc9
+29 Sep</c:v>
+                </c:pt>
               </c:strCache>
             </c:strRef>
           </c:cat>
           <c:val>
             <c:numRef>
-              <c:f>Sheet1!$B$2:$B$6</c:f>
+              <c:f>Sheet1!$B$2:$B$7</c:f>
               <c:numCache>
                 <c:formatCode>General</c:formatCode>
-                <c:ptCount val="5"/>
+                <c:ptCount val="6"/>
                 <c:pt idx="0">
                   <c:v>128</c:v>
                 </c:pt>
@@ -262,6 +274,9 @@
                   <c:v>129</c:v>
                 </c:pt>
                 <c:pt idx="4">
+                  <c:v>132</c:v>
+                </c:pt>
+                <c:pt idx="5">
                   <c:v>132</c:v>
                 </c:pt>
               </c:numCache>
@@ -2306,7 +2321,7 @@
           <a:p>
             <a:r>
               <a:rPr lang="en-GB" dirty="0"/>
-              <a:t>GO_LIVE_BUILD_PLAN 6.5 (freeze ruleset 'Go-live freeze'), 2.5 (PITR re-declined on cost 28 Sept, containment stated), 6.1 (staging-only rule), 4.4 and 6.3 (continuous through the first month), and the rc8 decision to ship on Next 14.2.35 with rc9 as the Next 15.5 upgrade (PR #73, draft).</a:t>
+              <a:t>GO_LIVE_BUILD_PLAN 6.5 (freeze ruleset 'Go-live freeze'), 2.5 (PITR re-declined on cost 28 Sept, containment stated), 6.1 (staging-only rule), 4.4 and 6.3 (continuous through the first month), and the rc8 decision to ship on Next 14.2.35 with rc9 as the Next 15.5 upgrade; rc9 (PR #73) merged 29 Sept 09:07 with the freeze lifted for one minute.</a:t>
             </a:r>
           </a:p>
         </p:txBody>
@@ -2400,7 +2415,7 @@
           <a:p>
             <a:r>
               <a:rPr lang="en-GB" dirty="0"/>
-              <a:t>Close on the five decisions. Context: the 23 Sept edition asked for two uninterrupted days; the cutover itself is now done. What remains is compliance and the live gateway key, both board-owned.</a:t>
+              <a:t>Close on the five decisions. rc9 (Next.js 15, tag v1.0.0-rc9 at 9dab9a2, 132/132 on staging) went live 29 Sept 09:07; freeze ruleset restored 09:08. Context: the 23 Sept edition asked for two uninterrupted days; the cutover itself is now done. What remains is compliance and the live gateway key, both board-owned.</a:t>
             </a:r>
           </a:p>
         </p:txBody>
@@ -30890,7 +30905,7 @@
                 </a:solidFill>
                 <a:latin typeface="Calibri"/>
               </a:rPr>
-              <a:t>suites passing on rc8</a:t>
+              <a:t>suites passing on rc9</a:t>
             </a:r>
           </a:p>
         </p:txBody>
@@ -31315,7 +31330,7 @@
                 </a:solidFill>
                 <a:latin typeface="Calibri"/>
               </a:rPr>
-              <a:t>rc4 → rc8 in five days; rc8 passed 132/132</a:t>
+              <a:t>rc4 → rc9; rc9 (Next.js 15) live, 132/132</a:t>
             </a:r>
           </a:p>
         </p:txBody>
@@ -33058,7 +33073,7 @@
                 </a:solidFill>
                 <a:latin typeface="Calibri"/>
               </a:rPr>
-              <a:t>Every figure is from a committed run record or test result, 24–28 September.</a:t>
+              <a:t>Every figure is from a committed run record or test result, 24–29 September.</a:t>
             </a:r>
           </a:p>
         </p:txBody>
@@ -33174,7 +33189,7 @@
                 </a:solidFill>
                 <a:latin typeface="Calibri"/>
               </a:rPr>
-              <a:t>suites passed on rc8</a:t>
+              <a:t>suites passed, rc8 and rc9</a:t>
             </a:r>
           </a:p>
         </p:txBody>
@@ -33209,7 +33224,7 @@
                 </a:solidFill>
                 <a:latin typeface="Calibri"/>
               </a:rPr>
-              <a:t>The release that went live, 28 Sept. It passed 131 in one full run plus 1 re-run on its own, after a one-off hang</a:t>
+              <a:t>rc8 went live on 28 Sept. rc9, the Next.js 15 upgrade that clears the critical advisory, replaced it on 29 Sept</a:t>
             </a:r>
           </a:p>
         </p:txBody>
@@ -33360,7 +33375,7 @@
                 </a:solidFill>
                 <a:latin typeface="Calibri"/>
               </a:rPr>
-              <a:t>Passive scan on production and active scan on the release: no High findings. The external pen test is also complete</a:t>
+              <a:t>Passive scan on production and active scan on rc8: no High findings. The external pen test is also complete</a:t>
             </a:r>
           </a:p>
         </p:txBody>
@@ -33846,7 +33861,7 @@
                 </a:solidFill>
                 <a:latin typeface="Cambria"/>
               </a:rPr>
-              <a:t>The cutover window, 23–28 September</a:t>
+              <a:t>The cutover window, 23–29 September</a:t>
             </a:r>
           </a:p>
         </p:txBody>
@@ -33881,7 +33896,7 @@
                 </a:solidFill>
                 <a:latin typeface="Calibri"/>
               </a:rPr>
-              <a:t>What was asked for as two uninterrupted days ran as six, alongside live verification and fixes.</a:t>
+              <a:t>What was asked for as two uninterrupted days ran as six, then a seventh for the first release under the freeze.</a:t>
             </a:r>
           </a:p>
         </p:txBody>
@@ -33894,8 +33909,8 @@
         </p:nvCxnSpPr>
         <p:spPr>
           <a:xfrm>
-            <a:off x="1417319" y="2212848"/>
-            <a:ext cx="9326880" cy="0"/>
+            <a:off x="1280160" y="2212848"/>
+            <a:ext cx="9546336" cy="0"/>
           </a:xfrm>
           <a:prstGeom prst="line">
             <a:avLst/>
@@ -33929,7 +33944,7 @@
         </p:nvSpPr>
         <p:spPr>
           <a:xfrm>
-            <a:off x="1088136" y="1883664"/>
+            <a:off x="950976" y="1883664"/>
             <a:ext cx="658368" cy="658368"/>
           </a:xfrm>
           <a:prstGeom prst="ellipse">
@@ -33983,7 +33998,7 @@
         <p:spPr>
           <a:xfrm>
             <a:off x="548640" y="2615184"/>
-            <a:ext cx="1737360" cy="228600"/>
+            <a:ext cx="1463040" cy="228600"/>
           </a:xfrm>
           <a:prstGeom prst="rect">
             <a:avLst/>
@@ -34018,7 +34033,7 @@
         <p:spPr>
           <a:xfrm>
             <a:off x="548640" y="2926080"/>
-            <a:ext cx="1737360" cy="3017520"/>
+            <a:ext cx="1463040" cy="3017520"/>
           </a:xfrm>
           <a:prstGeom prst="roundRect">
             <a:avLst>
@@ -34063,8 +34078,8 @@
         </p:nvSpPr>
         <p:spPr>
           <a:xfrm>
-            <a:off x="685800" y="3063240"/>
-            <a:ext cx="1463039" cy="502920"/>
+            <a:off x="658368" y="3063240"/>
+            <a:ext cx="1243584" cy="502920"/>
           </a:xfrm>
           <a:prstGeom prst="rect">
             <a:avLst/>
@@ -34079,7 +34094,7 @@
           <a:p>
             <a:pPr algn="l"/>
             <a:r>
-              <a:rPr sz="1300" b="1" i="0">
+              <a:rPr sz="1200" b="1" i="0">
                 <a:solidFill>
                   <a:srgbClr val="003366"/>
                 </a:solidFill>
@@ -34098,8 +34113,8 @@
         </p:nvSpPr>
         <p:spPr>
           <a:xfrm>
-            <a:off x="685800" y="3657600"/>
-            <a:ext cx="1463039" cy="731520"/>
+            <a:off x="658368" y="3657600"/>
+            <a:ext cx="1243584" cy="731520"/>
           </a:xfrm>
           <a:prstGeom prst="rect">
             <a:avLst/>
@@ -34114,7 +34129,7 @@
           <a:p>
             <a:pPr algn="l"/>
             <a:r>
-              <a:rPr sz="1050" b="0" i="0">
+              <a:rPr sz="1000" b="0" i="0">
                 <a:solidFill>
                   <a:srgbClr val="1C2B3A"/>
                 </a:solidFill>
@@ -34133,7 +34148,7 @@
         </p:nvSpPr>
         <p:spPr>
           <a:xfrm>
-            <a:off x="2953512" y="1883664"/>
+            <a:off x="2542032" y="1883664"/>
             <a:ext cx="658368" cy="658368"/>
           </a:xfrm>
           <a:prstGeom prst="ellipse">
@@ -34186,8 +34201,8 @@
         </p:nvSpPr>
         <p:spPr>
           <a:xfrm>
-            <a:off x="2414016" y="2615184"/>
-            <a:ext cx="1737360" cy="228600"/>
+            <a:off x="2139696" y="2615184"/>
+            <a:ext cx="1463040" cy="228600"/>
           </a:xfrm>
           <a:prstGeom prst="rect">
             <a:avLst/>
@@ -34221,8 +34236,8 @@
         </p:nvSpPr>
         <p:spPr>
           <a:xfrm>
-            <a:off x="2414016" y="2926080"/>
-            <a:ext cx="1737360" cy="3017520"/>
+            <a:off x="2139696" y="2926080"/>
+            <a:ext cx="1463040" cy="3017520"/>
           </a:xfrm>
           <a:prstGeom prst="roundRect">
             <a:avLst>
@@ -34267,8 +34282,8 @@
         </p:nvSpPr>
         <p:spPr>
           <a:xfrm>
-            <a:off x="2551176" y="3063240"/>
-            <a:ext cx="1463039" cy="502920"/>
+            <a:off x="2249424" y="3063240"/>
+            <a:ext cx="1243584" cy="502920"/>
           </a:xfrm>
           <a:prstGeom prst="rect">
             <a:avLst/>
@@ -34283,7 +34298,7 @@
           <a:p>
             <a:pPr algn="l"/>
             <a:r>
-              <a:rPr sz="1300" b="1" i="0">
+              <a:rPr sz="1200" b="1" i="0">
                 <a:solidFill>
                   <a:srgbClr val="003366"/>
                 </a:solidFill>
@@ -34302,8 +34317,8 @@
         </p:nvSpPr>
         <p:spPr>
           <a:xfrm>
-            <a:off x="2551176" y="3657600"/>
-            <a:ext cx="1463039" cy="731520"/>
+            <a:off x="2249424" y="3657600"/>
+            <a:ext cx="1243584" cy="731520"/>
           </a:xfrm>
           <a:prstGeom prst="rect">
             <a:avLst/>
@@ -34318,7 +34333,7 @@
           <a:p>
             <a:pPr algn="l"/>
             <a:r>
-              <a:rPr sz="1050" b="0" i="0">
+              <a:rPr sz="1000" b="0" i="0">
                 <a:solidFill>
                   <a:srgbClr val="1C2B3A"/>
                 </a:solidFill>
@@ -34337,8 +34352,8 @@
         </p:nvSpPr>
         <p:spPr>
           <a:xfrm>
-            <a:off x="2551176" y="4370832"/>
-            <a:ext cx="1463039" cy="731520"/>
+            <a:off x="2249424" y="4370832"/>
+            <a:ext cx="1243584" cy="731520"/>
           </a:xfrm>
           <a:prstGeom prst="rect">
             <a:avLst/>
@@ -34353,7 +34368,7 @@
           <a:p>
             <a:pPr algn="l"/>
             <a:r>
-              <a:rPr sz="1050" b="0" i="0">
+              <a:rPr sz="1000" b="0" i="0">
                 <a:solidFill>
                   <a:srgbClr val="1C2B3A"/>
                 </a:solidFill>
@@ -34372,8 +34387,8 @@
         </p:nvSpPr>
         <p:spPr>
           <a:xfrm>
-            <a:off x="2551176" y="5084064"/>
-            <a:ext cx="1463039" cy="731520"/>
+            <a:off x="2249424" y="5084064"/>
+            <a:ext cx="1243584" cy="731520"/>
           </a:xfrm>
           <a:prstGeom prst="rect">
             <a:avLst/>
@@ -34388,7 +34403,7 @@
           <a:p>
             <a:pPr algn="l"/>
             <a:r>
-              <a:rPr sz="1050" b="0" i="0">
+              <a:rPr sz="1000" b="0" i="0">
                 <a:solidFill>
                   <a:srgbClr val="1C2B3A"/>
                 </a:solidFill>
@@ -34407,7 +34422,7 @@
         </p:nvSpPr>
         <p:spPr>
           <a:xfrm>
-            <a:off x="4818888" y="1883664"/>
+            <a:off x="4133087" y="1883664"/>
             <a:ext cx="658368" cy="658368"/>
           </a:xfrm>
           <a:prstGeom prst="ellipse">
@@ -34460,8 +34475,8 @@
         </p:nvSpPr>
         <p:spPr>
           <a:xfrm>
-            <a:off x="4279392" y="2615184"/>
-            <a:ext cx="1737360" cy="228600"/>
+            <a:off x="3730752" y="2615184"/>
+            <a:ext cx="1463040" cy="228600"/>
           </a:xfrm>
           <a:prstGeom prst="rect">
             <a:avLst/>
@@ -34495,8 +34510,8 @@
         </p:nvSpPr>
         <p:spPr>
           <a:xfrm>
-            <a:off x="4279392" y="2926080"/>
-            <a:ext cx="1737360" cy="3017520"/>
+            <a:off x="3730752" y="2926080"/>
+            <a:ext cx="1463040" cy="3017520"/>
           </a:xfrm>
           <a:prstGeom prst="roundRect">
             <a:avLst>
@@ -34541,8 +34556,8 @@
         </p:nvSpPr>
         <p:spPr>
           <a:xfrm>
-            <a:off x="4416552" y="3063240"/>
-            <a:ext cx="1463039" cy="502920"/>
+            <a:off x="3840480" y="3063240"/>
+            <a:ext cx="1243584" cy="502920"/>
           </a:xfrm>
           <a:prstGeom prst="rect">
             <a:avLst/>
@@ -34557,7 +34572,7 @@
           <a:p>
             <a:pPr algn="l"/>
             <a:r>
-              <a:rPr sz="1300" b="1" i="0">
+              <a:rPr sz="1200" b="1" i="0">
                 <a:solidFill>
                   <a:srgbClr val="003366"/>
                 </a:solidFill>
@@ -34576,8 +34591,8 @@
         </p:nvSpPr>
         <p:spPr>
           <a:xfrm>
-            <a:off x="4416552" y="3657600"/>
-            <a:ext cx="1463039" cy="731520"/>
+            <a:off x="3840480" y="3657600"/>
+            <a:ext cx="1243584" cy="731520"/>
           </a:xfrm>
           <a:prstGeom prst="rect">
             <a:avLst/>
@@ -34592,7 +34607,7 @@
           <a:p>
             <a:pPr algn="l"/>
             <a:r>
-              <a:rPr sz="1050" b="0" i="0">
+              <a:rPr sz="1000" b="0" i="0">
                 <a:solidFill>
                   <a:srgbClr val="1C2B3A"/>
                 </a:solidFill>
@@ -34611,8 +34626,8 @@
         </p:nvSpPr>
         <p:spPr>
           <a:xfrm>
-            <a:off x="4416552" y="4370832"/>
-            <a:ext cx="1463039" cy="731520"/>
+            <a:off x="3840480" y="4370832"/>
+            <a:ext cx="1243584" cy="731520"/>
           </a:xfrm>
           <a:prstGeom prst="rect">
             <a:avLst/>
@@ -34627,7 +34642,7 @@
           <a:p>
             <a:pPr algn="l"/>
             <a:r>
-              <a:rPr sz="1050" b="0" i="0">
+              <a:rPr sz="1000" b="0" i="0">
                 <a:solidFill>
                   <a:srgbClr val="1C2B3A"/>
                 </a:solidFill>
@@ -34646,8 +34661,8 @@
         </p:nvSpPr>
         <p:spPr>
           <a:xfrm>
-            <a:off x="4416552" y="5084064"/>
-            <a:ext cx="1463039" cy="731520"/>
+            <a:off x="3840480" y="5084064"/>
+            <a:ext cx="1243584" cy="731520"/>
           </a:xfrm>
           <a:prstGeom prst="rect">
             <a:avLst/>
@@ -34662,7 +34677,7 @@
           <a:p>
             <a:pPr algn="l"/>
             <a:r>
-              <a:rPr sz="1050" b="0" i="0">
+              <a:rPr sz="1000" b="0" i="0">
                 <a:solidFill>
                   <a:srgbClr val="1C2B3A"/>
                 </a:solidFill>
@@ -34681,7 +34696,7 @@
         </p:nvSpPr>
         <p:spPr>
           <a:xfrm>
-            <a:off x="6684264" y="1883664"/>
+            <a:off x="5724144" y="1883664"/>
             <a:ext cx="658368" cy="658368"/>
           </a:xfrm>
           <a:prstGeom prst="ellipse">
@@ -34734,8 +34749,8 @@
         </p:nvSpPr>
         <p:spPr>
           <a:xfrm>
-            <a:off x="6144768" y="2615184"/>
-            <a:ext cx="1737360" cy="228600"/>
+            <a:off x="5321808" y="2615184"/>
+            <a:ext cx="1463040" cy="228600"/>
           </a:xfrm>
           <a:prstGeom prst="rect">
             <a:avLst/>
@@ -34769,8 +34784,8 @@
         </p:nvSpPr>
         <p:spPr>
           <a:xfrm>
-            <a:off x="6144768" y="2926080"/>
-            <a:ext cx="1737360" cy="3017520"/>
+            <a:off x="5321808" y="2926080"/>
+            <a:ext cx="1463040" cy="3017520"/>
           </a:xfrm>
           <a:prstGeom prst="roundRect">
             <a:avLst>
@@ -34815,8 +34830,8 @@
         </p:nvSpPr>
         <p:spPr>
           <a:xfrm>
-            <a:off x="6281928" y="3063240"/>
-            <a:ext cx="1463039" cy="502920"/>
+            <a:off x="5431536" y="3063240"/>
+            <a:ext cx="1243584" cy="502920"/>
           </a:xfrm>
           <a:prstGeom prst="rect">
             <a:avLst/>
@@ -34831,7 +34846,7 @@
           <a:p>
             <a:pPr algn="l"/>
             <a:r>
-              <a:rPr sz="1300" b="1" i="0">
+              <a:rPr sz="1200" b="1" i="0">
                 <a:solidFill>
                   <a:srgbClr val="003366"/>
                 </a:solidFill>
@@ -34850,8 +34865,8 @@
         </p:nvSpPr>
         <p:spPr>
           <a:xfrm>
-            <a:off x="6281928" y="3657600"/>
-            <a:ext cx="1463039" cy="731520"/>
+            <a:off x="5431536" y="3657600"/>
+            <a:ext cx="1243584" cy="731520"/>
           </a:xfrm>
           <a:prstGeom prst="rect">
             <a:avLst/>
@@ -34866,7 +34881,7 @@
           <a:p>
             <a:pPr algn="l"/>
             <a:r>
-              <a:rPr sz="1050" b="0" i="0">
+              <a:rPr sz="1000" b="0" i="0">
                 <a:solidFill>
                   <a:srgbClr val="1C2B3A"/>
                 </a:solidFill>
@@ -34885,8 +34900,8 @@
         </p:nvSpPr>
         <p:spPr>
           <a:xfrm>
-            <a:off x="6281928" y="4370832"/>
-            <a:ext cx="1463039" cy="731520"/>
+            <a:off x="5431536" y="4370832"/>
+            <a:ext cx="1243584" cy="731520"/>
           </a:xfrm>
           <a:prstGeom prst="rect">
             <a:avLst/>
@@ -34901,7 +34916,7 @@
           <a:p>
             <a:pPr algn="l"/>
             <a:r>
-              <a:rPr sz="1050" b="0" i="0">
+              <a:rPr sz="1000" b="0" i="0">
                 <a:solidFill>
                   <a:srgbClr val="1C2B3A"/>
                 </a:solidFill>
@@ -34920,8 +34935,8 @@
         </p:nvSpPr>
         <p:spPr>
           <a:xfrm>
-            <a:off x="6281928" y="5084064"/>
-            <a:ext cx="1463039" cy="731520"/>
+            <a:off x="5431536" y="5084064"/>
+            <a:ext cx="1243584" cy="731520"/>
           </a:xfrm>
           <a:prstGeom prst="rect">
             <a:avLst/>
@@ -34936,7 +34951,7 @@
           <a:p>
             <a:pPr algn="l"/>
             <a:r>
-              <a:rPr sz="1050" b="0" i="0">
+              <a:rPr sz="1000" b="0" i="0">
                 <a:solidFill>
                   <a:srgbClr val="1C2B3A"/>
                 </a:solidFill>
@@ -34955,7 +34970,7 @@
         </p:nvSpPr>
         <p:spPr>
           <a:xfrm>
-            <a:off x="8549640" y="1883664"/>
+            <a:off x="7315200" y="1883664"/>
             <a:ext cx="658368" cy="658368"/>
           </a:xfrm>
           <a:prstGeom prst="ellipse">
@@ -35008,8 +35023,8 @@
         </p:nvSpPr>
         <p:spPr>
           <a:xfrm>
-            <a:off x="8010144" y="2615184"/>
-            <a:ext cx="1737360" cy="228600"/>
+            <a:off x="6912864" y="2615184"/>
+            <a:ext cx="1463040" cy="228600"/>
           </a:xfrm>
           <a:prstGeom prst="rect">
             <a:avLst/>
@@ -35043,8 +35058,8 @@
         </p:nvSpPr>
         <p:spPr>
           <a:xfrm>
-            <a:off x="8010144" y="2926080"/>
-            <a:ext cx="1737360" cy="3017520"/>
+            <a:off x="6912864" y="2926080"/>
+            <a:ext cx="1463040" cy="3017520"/>
           </a:xfrm>
           <a:prstGeom prst="roundRect">
             <a:avLst>
@@ -35089,8 +35104,8 @@
         </p:nvSpPr>
         <p:spPr>
           <a:xfrm>
-            <a:off x="8147304" y="3063240"/>
-            <a:ext cx="1463039" cy="502920"/>
+            <a:off x="7022592" y="3063240"/>
+            <a:ext cx="1243584" cy="502920"/>
           </a:xfrm>
           <a:prstGeom prst="rect">
             <a:avLst/>
@@ -35105,7 +35120,7 @@
           <a:p>
             <a:pPr algn="l"/>
             <a:r>
-              <a:rPr sz="1300" b="1" i="0">
+              <a:rPr sz="1200" b="1" i="0">
                 <a:solidFill>
                   <a:srgbClr val="003366"/>
                 </a:solidFill>
@@ -35124,8 +35139,8 @@
         </p:nvSpPr>
         <p:spPr>
           <a:xfrm>
-            <a:off x="8147304" y="3657600"/>
-            <a:ext cx="1463039" cy="731520"/>
+            <a:off x="7022592" y="3657600"/>
+            <a:ext cx="1243584" cy="731520"/>
           </a:xfrm>
           <a:prstGeom prst="rect">
             <a:avLst/>
@@ -35140,7 +35155,7 @@
           <a:p>
             <a:pPr algn="l"/>
             <a:r>
-              <a:rPr sz="1050" b="0" i="0">
+              <a:rPr sz="1000" b="0" i="0">
                 <a:solidFill>
                   <a:srgbClr val="1C2B3A"/>
                 </a:solidFill>
@@ -35159,8 +35174,8 @@
         </p:nvSpPr>
         <p:spPr>
           <a:xfrm>
-            <a:off x="8147304" y="4370832"/>
-            <a:ext cx="1463039" cy="731520"/>
+            <a:off x="7022592" y="4370832"/>
+            <a:ext cx="1243584" cy="731520"/>
           </a:xfrm>
           <a:prstGeom prst="rect">
             <a:avLst/>
@@ -35175,7 +35190,7 @@
           <a:p>
             <a:pPr algn="l"/>
             <a:r>
-              <a:rPr sz="1050" b="0" i="0">
+              <a:rPr sz="1000" b="0" i="0">
                 <a:solidFill>
                   <a:srgbClr val="1C2B3A"/>
                 </a:solidFill>
@@ -35194,7 +35209,7 @@
         </p:nvSpPr>
         <p:spPr>
           <a:xfrm>
-            <a:off x="10415015" y="1883664"/>
+            <a:off x="8906256" y="1883664"/>
             <a:ext cx="658368" cy="658368"/>
           </a:xfrm>
           <a:prstGeom prst="ellipse">
@@ -35247,8 +35262,8 @@
         </p:nvSpPr>
         <p:spPr>
           <a:xfrm>
-            <a:off x="9875519" y="2615184"/>
-            <a:ext cx="1737360" cy="228600"/>
+            <a:off x="8503920" y="2615184"/>
+            <a:ext cx="1463040" cy="228600"/>
           </a:xfrm>
           <a:prstGeom prst="rect">
             <a:avLst/>
@@ -35282,8 +35297,8 @@
         </p:nvSpPr>
         <p:spPr>
           <a:xfrm>
-            <a:off x="9875519" y="2926080"/>
-            <a:ext cx="1737360" cy="3017520"/>
+            <a:off x="8503920" y="2926080"/>
+            <a:ext cx="1463040" cy="3017520"/>
           </a:xfrm>
           <a:prstGeom prst="roundRect">
             <a:avLst>
@@ -35328,8 +35343,8 @@
         </p:nvSpPr>
         <p:spPr>
           <a:xfrm>
-            <a:off x="10012680" y="3063240"/>
-            <a:ext cx="1463039" cy="502920"/>
+            <a:off x="8613648" y="3063240"/>
+            <a:ext cx="1243584" cy="502920"/>
           </a:xfrm>
           <a:prstGeom prst="rect">
             <a:avLst/>
@@ -35344,7 +35359,7 @@
           <a:p>
             <a:pPr algn="l"/>
             <a:r>
-              <a:rPr sz="1300" b="1" i="0">
+              <a:rPr sz="1200" b="1" i="0">
                 <a:solidFill>
                   <a:srgbClr val="1F7A4D"/>
                 </a:solidFill>
@@ -35363,8 +35378,8 @@
         </p:nvSpPr>
         <p:spPr>
           <a:xfrm>
-            <a:off x="10012680" y="3657600"/>
-            <a:ext cx="1463039" cy="731520"/>
+            <a:off x="8613648" y="3657600"/>
+            <a:ext cx="1243584" cy="731520"/>
           </a:xfrm>
           <a:prstGeom prst="rect">
             <a:avLst/>
@@ -35379,7 +35394,7 @@
           <a:p>
             <a:pPr algn="l"/>
             <a:r>
-              <a:rPr sz="1050" b="0" i="0">
+              <a:rPr sz="1000" b="0" i="0">
                 <a:solidFill>
                   <a:srgbClr val="1C2B3A"/>
                 </a:solidFill>
@@ -35398,8 +35413,8 @@
         </p:nvSpPr>
         <p:spPr>
           <a:xfrm>
-            <a:off x="10012680" y="4370832"/>
-            <a:ext cx="1463039" cy="731520"/>
+            <a:off x="8613648" y="4370832"/>
+            <a:ext cx="1243584" cy="731520"/>
           </a:xfrm>
           <a:prstGeom prst="rect">
             <a:avLst/>
@@ -35414,7 +35429,7 @@
           <a:p>
             <a:pPr algn="l"/>
             <a:r>
-              <a:rPr sz="1050" b="0" i="0">
+              <a:rPr sz="1000" b="0" i="0">
                 <a:solidFill>
                   <a:srgbClr val="1C2B3A"/>
                 </a:solidFill>
@@ -35433,8 +35448,8 @@
         </p:nvSpPr>
         <p:spPr>
           <a:xfrm>
-            <a:off x="10012680" y="5084064"/>
-            <a:ext cx="1463039" cy="731520"/>
+            <a:off x="8613648" y="5084064"/>
+            <a:ext cx="1243584" cy="731520"/>
           </a:xfrm>
           <a:prstGeom prst="rect">
             <a:avLst/>
@@ -35449,7 +35464,7 @@
           <a:p>
             <a:pPr algn="l"/>
             <a:r>
-              <a:rPr sz="1050" b="0" i="0">
+              <a:rPr sz="1000" b="0" i="0">
                 <a:solidFill>
                   <a:srgbClr val="1C2B3A"/>
                 </a:solidFill>
@@ -35462,7 +35477,281 @@
       </p:sp>
       <p:sp>
         <p:nvSpPr>
-          <p:cNvPr id="44" name="TextBox 43"/>
+          <p:cNvPr id="44" name="Oval 43"/>
+          <p:cNvSpPr/>
+          <p:nvPr/>
+        </p:nvSpPr>
+        <p:spPr>
+          <a:xfrm>
+            <a:off x="10497312" y="1883664"/>
+            <a:ext cx="658368" cy="658368"/>
+          </a:xfrm>
+          <a:prstGeom prst="ellipse">
+            <a:avLst/>
+          </a:prstGeom>
+          <a:solidFill>
+            <a:srgbClr val="1F7A4D"/>
+          </a:solidFill>
+          <a:ln>
+            <a:noFill/>
+          </a:ln>
+          <a:effectLst/>
+        </p:spPr>
+        <p:style>
+          <a:lnRef idx="1">
+            <a:schemeClr val="accent1"/>
+          </a:lnRef>
+          <a:fillRef idx="3">
+            <a:schemeClr val="accent1"/>
+          </a:fillRef>
+          <a:effectRef idx="2">
+            <a:schemeClr val="accent1"/>
+          </a:effectRef>
+          <a:fontRef idx="minor">
+            <a:schemeClr val="lt1"/>
+          </a:fontRef>
+        </p:style>
+        <p:txBody>
+          <a:bodyPr rtlCol="0" anchor="ctr" lIns="0" rIns="0" tIns="0" bIns="0"/>
+          <a:lstStyle/>
+          <a:p>
+            <a:pPr algn="ctr"/>
+            <a:r>
+              <a:rPr sz="1700" b="1">
+                <a:solidFill>
+                  <a:srgbClr val="FFFFFF"/>
+                </a:solidFill>
+                <a:latin typeface="Cambria"/>
+              </a:rPr>
+              <a:t>29</a:t>
+            </a:r>
+          </a:p>
+        </p:txBody>
+      </p:sp>
+      <p:sp>
+        <p:nvSpPr>
+          <p:cNvPr id="45" name="TextBox 44"/>
+          <p:cNvSpPr txBox="1"/>
+          <p:nvPr/>
+        </p:nvSpPr>
+        <p:spPr>
+          <a:xfrm>
+            <a:off x="10094976" y="2615184"/>
+            <a:ext cx="1463040" cy="228600"/>
+          </a:xfrm>
+          <a:prstGeom prst="rect">
+            <a:avLst/>
+          </a:prstGeom>
+          <a:noFill/>
+        </p:spPr>
+        <p:txBody>
+          <a:bodyPr wrap="square" lIns="0" rIns="0" tIns="0" bIns="0" anchor="t">
+            <a:spAutoFit/>
+          </a:bodyPr>
+          <a:lstStyle/>
+          <a:p>
+            <a:pPr algn="ctr"/>
+            <a:r>
+              <a:rPr sz="900" b="1" i="0" spc="100">
+                <a:solidFill>
+                  <a:srgbClr val="7A8A9B"/>
+                </a:solidFill>
+                <a:latin typeface="Calibri"/>
+              </a:rPr>
+              <a:t>MON · SEPT</a:t>
+            </a:r>
+          </a:p>
+        </p:txBody>
+      </p:sp>
+      <p:sp>
+        <p:nvSpPr>
+          <p:cNvPr id="46" name="Rounded Rectangle 45"/>
+          <p:cNvSpPr/>
+          <p:nvPr/>
+        </p:nvSpPr>
+        <p:spPr>
+          <a:xfrm>
+            <a:off x="10094976" y="2926080"/>
+            <a:ext cx="1463040" cy="3017520"/>
+          </a:xfrm>
+          <a:prstGeom prst="roundRect">
+            <a:avLst>
+              <a:gd name="adj" fmla="val 6000"/>
+            </a:avLst>
+          </a:prstGeom>
+          <a:solidFill>
+            <a:srgbClr val="EAF1F9"/>
+          </a:solidFill>
+          <a:ln w="9525">
+            <a:solidFill>
+              <a:srgbClr val="1F7A4D"/>
+            </a:solidFill>
+          </a:ln>
+          <a:effectLst/>
+        </p:spPr>
+        <p:style>
+          <a:lnRef idx="1">
+            <a:schemeClr val="accent1"/>
+          </a:lnRef>
+          <a:fillRef idx="3">
+            <a:schemeClr val="accent1"/>
+          </a:fillRef>
+          <a:effectRef idx="2">
+            <a:schemeClr val="accent1"/>
+          </a:effectRef>
+          <a:fontRef idx="minor">
+            <a:schemeClr val="lt1"/>
+          </a:fontRef>
+        </p:style>
+        <p:txBody>
+          <a:bodyPr rtlCol="0" anchor="ctr"/>
+          <a:lstStyle/>
+          <a:p/>
+        </p:txBody>
+      </p:sp>
+      <p:sp>
+        <p:nvSpPr>
+          <p:cNvPr id="47" name="TextBox 46"/>
+          <p:cNvSpPr txBox="1"/>
+          <p:nvPr/>
+        </p:nvSpPr>
+        <p:spPr>
+          <a:xfrm>
+            <a:off x="10204704" y="3063240"/>
+            <a:ext cx="1243584" cy="502920"/>
+          </a:xfrm>
+          <a:prstGeom prst="rect">
+            <a:avLst/>
+          </a:prstGeom>
+          <a:noFill/>
+        </p:spPr>
+        <p:txBody>
+          <a:bodyPr wrap="square" lIns="0" rIns="0" tIns="0" bIns="0" anchor="t">
+            <a:spAutoFit/>
+          </a:bodyPr>
+          <a:lstStyle/>
+          <a:p>
+            <a:pPr algn="l"/>
+            <a:r>
+              <a:rPr sz="1200" b="1" i="0">
+                <a:solidFill>
+                  <a:srgbClr val="1F7A4D"/>
+                </a:solidFill>
+                <a:latin typeface="Cambria"/>
+              </a:rPr>
+              <a:t>First release live</a:t>
+            </a:r>
+          </a:p>
+        </p:txBody>
+      </p:sp>
+      <p:sp>
+        <p:nvSpPr>
+          <p:cNvPr id="48" name="TextBox 47"/>
+          <p:cNvSpPr txBox="1"/>
+          <p:nvPr/>
+        </p:nvSpPr>
+        <p:spPr>
+          <a:xfrm>
+            <a:off x="10204704" y="3657600"/>
+            <a:ext cx="1243584" cy="731520"/>
+          </a:xfrm>
+          <a:prstGeom prst="rect">
+            <a:avLst/>
+          </a:prstGeom>
+          <a:noFill/>
+        </p:spPr>
+        <p:txBody>
+          <a:bodyPr wrap="square" lIns="0" rIns="0" tIns="0" bIns="0" anchor="t">
+            <a:spAutoFit/>
+          </a:bodyPr>
+          <a:lstStyle/>
+          <a:p>
+            <a:pPr algn="l"/>
+            <a:r>
+              <a:rPr sz="1000" b="0" i="0">
+                <a:solidFill>
+                  <a:srgbClr val="1C2B3A"/>
+                </a:solidFill>
+                <a:latin typeface="Calibri"/>
+              </a:rPr>
+              <a:t>rc9: Next.js 15, 132/132</a:t>
+            </a:r>
+          </a:p>
+        </p:txBody>
+      </p:sp>
+      <p:sp>
+        <p:nvSpPr>
+          <p:cNvPr id="49" name="TextBox 48"/>
+          <p:cNvSpPr txBox="1"/>
+          <p:nvPr/>
+        </p:nvSpPr>
+        <p:spPr>
+          <a:xfrm>
+            <a:off x="10204704" y="4370832"/>
+            <a:ext cx="1243584" cy="731520"/>
+          </a:xfrm>
+          <a:prstGeom prst="rect">
+            <a:avLst/>
+          </a:prstGeom>
+          <a:noFill/>
+        </p:spPr>
+        <p:txBody>
+          <a:bodyPr wrap="square" lIns="0" rIns="0" tIns="0" bIns="0" anchor="t">
+            <a:spAutoFit/>
+          </a:bodyPr>
+          <a:lstStyle/>
+          <a:p>
+            <a:pPr algn="l"/>
+            <a:r>
+              <a:rPr sz="1000" b="0" i="0">
+                <a:solidFill>
+                  <a:srgbClr val="1C2B3A"/>
+                </a:solidFill>
+                <a:latin typeface="Calibri"/>
+              </a:rPr>
+              <a:t>Critical advisory cleared</a:t>
+            </a:r>
+          </a:p>
+        </p:txBody>
+      </p:sp>
+      <p:sp>
+        <p:nvSpPr>
+          <p:cNvPr id="50" name="TextBox 49"/>
+          <p:cNvSpPr txBox="1"/>
+          <p:nvPr/>
+        </p:nvSpPr>
+        <p:spPr>
+          <a:xfrm>
+            <a:off x="10204704" y="5084064"/>
+            <a:ext cx="1243584" cy="731520"/>
+          </a:xfrm>
+          <a:prstGeom prst="rect">
+            <a:avLst/>
+          </a:prstGeom>
+          <a:noFill/>
+        </p:spPr>
+        <p:txBody>
+          <a:bodyPr wrap="square" lIns="0" rIns="0" tIns="0" bIns="0" anchor="t">
+            <a:spAutoFit/>
+          </a:bodyPr>
+          <a:lstStyle/>
+          <a:p>
+            <a:pPr algn="l"/>
+            <a:r>
+              <a:rPr sz="1000" b="0" i="0">
+                <a:solidFill>
+                  <a:srgbClr val="1C2B3A"/>
+                </a:solidFill>
+                <a:latin typeface="Calibri"/>
+              </a:rPr>
+              <a:t>Freeze lifted 1 min, restored</a:t>
+            </a:r>
+          </a:p>
+        </p:txBody>
+      </p:sp>
+      <p:sp>
+        <p:nvSpPr>
+          <p:cNvPr id="51" name="TextBox 50"/>
           <p:cNvSpPr txBox="1"/>
           <p:nvPr/>
         </p:nvSpPr>
@@ -35490,7 +35779,7 @@
                 </a:solidFill>
                 <a:latin typeface="Calibri"/>
               </a:rPr>
-              <a:t>Five release candidates in six days. </a:t>
+              <a:t>Six release candidates in seven days. </a:t>
             </a:r>
             <a:r>
               <a:rPr sz="1200" b="0" i="0">
@@ -35499,14 +35788,14 @@
                 </a:solidFill>
                 <a:latin typeface="Calibri"/>
               </a:rPr>
-              <a:t>Each was retired by a real finding (rule 7), and each passed the full suite before it was tagged.</a:t>
-            </a:r>
-          </a:p>
-        </p:txBody>
-      </p:sp>
-      <p:sp>
-        <p:nvSpPr>
-          <p:cNvPr id="45" name="TextBox 44"/>
+              <a:t>Each passed the full suite before it was tagged, and rc9 showed a fix can ship under the freeze.</a:t>
+            </a:r>
+          </a:p>
+        </p:txBody>
+      </p:sp>
+      <p:sp>
+        <p:nvSpPr>
+          <p:cNvPr id="52" name="TextBox 51"/>
           <p:cNvSpPr txBox="1"/>
           <p:nvPr/>
         </p:nvSpPr>
@@ -36003,7 +36292,7 @@
                 </a:solidFill>
                 <a:latin typeface="Calibri"/>
               </a:rPr>
-              <a:t>rc5 went live 24 Sept; production now runs rc8</a:t>
+              <a:t>rc5 went live 24 Sept; production runs rc9 since 29 Sept</a:t>
             </a:r>
           </a:p>
         </p:txBody>
@@ -39264,7 +39553,7 @@
                 </a:solidFill>
                 <a:latin typeface="Calibri"/>
               </a:rPr>
-              <a:t>Run records in docs/verify-runs, 23–28 September</a:t>
+              <a:t>Run records in docs/verify-runs and the rc9 tag, 23–29 September</a:t>
             </a:r>
           </a:p>
         </p:txBody>
@@ -39352,7 +39641,7 @@
                 </a:solidFill>
                 <a:latin typeface="Calibri"/>
               </a:rPr>
-              <a:t>A change after the tag meant a new candidate and a full re-run. That is why there are five candidates in six days, not one.</a:t>
+              <a:t>A change after the tag meant a new candidate and a full re-run. That is why there are six candidates in seven days, not one.</a:t>
             </a:r>
           </a:p>
         </p:txBody>
@@ -40608,7 +40897,7 @@
                 </a:solidFill>
                 <a:latin typeface="Calibri"/>
               </a:rPr>
-              <a:t>rc9 waits</a:t>
+              <a:t>A fix ships under the freeze</a:t>
             </a:r>
           </a:p>
         </p:txBody>
@@ -40643,7 +40932,7 @@
                 </a:solidFill>
                 <a:latin typeface="Calibri"/>
               </a:rPr>
-              <a:t>The advisories are recorded as accepted risk for rc8.</a:t>
+              <a:t>The critical advisory accepted for rc8 is now cleared.</a:t>
             </a:r>
           </a:p>
         </p:txBody>
@@ -40678,7 +40967,7 @@
                 </a:solidFill>
                 <a:latin typeface="Calibri"/>
               </a:rPr>
-              <a:t>The Next.js 15 upgrade (security advisories) is ready as a draft and ships after onboarding.</a:t>
+              <a:t>rc9, the Next.js 15 upgrade, went live on 29 Sept. The freeze was lifted for the merge and restored one minute later.</a:t>
             </a:r>
           </a:p>
         </p:txBody>
@@ -46060,7 +46349,7 @@
                 </a:solidFill>
                 <a:latin typeface="Calibri"/>
               </a:rPr>
-              <a:t>Approve a release window for rc9 after onboarding</a:t>
+              <a:t>Name an owner and date for the first real payment</a:t>
             </a:r>
           </a:p>
         </p:txBody>
@@ -46095,7 +46384,7 @@
                 </a:solidFill>
                 <a:latin typeface="Calibri"/>
               </a:rPr>
-              <a:t>the Next.js 15 upgrade that retires the accepted security advisories.</a:t>
+              <a:t>the first collection, bank reconciliation and payout, each reconciled by hand (6.6).</a:t>
             </a:r>
           </a:p>
         </p:txBody>
@@ -46235,7 +46524,7 @@
                 </a:solidFill>
                 <a:latin typeface="Calibri"/>
               </a:rPr>
-              <a:t>suites passing on rc8</a:t>
+              <a:t>suites passing on rc9</a:t>
             </a:r>
           </a:p>
         </p:txBody>

</xml_diff>